<commit_message>
se actualiza readme y laminas de ppt
</commit_message>
<xml_diff>
--- a/docs/presentacion_f4_grupo_5.pptx
+++ b/docs/presentacion_f4_grupo_5.pptx
@@ -1360,7 +1360,7 @@
           </a:p>
           <a:p>
             <a:r>
-              <a:t>El trabajo se desarrolló progresivamente en cuatro fases. En la Fase 1 realizamos la exploración inicial de los datos y definimos el problema. En la Fase 2 incorporamos el análisis descriptivo y las primeras comparaciones. En la Fase 3 reorganizamos la solución mediante programación orientada a objetos, separando la lectura, limpieza, validación y ejecución del proceso. Finalmente, en la Fase 4 optimizamos la lectura de los datos, medimos la eficiencia y construimos las visualizaciones utilizadas para comunicar los resultados. Todo el proceso quedó documentado para que pueda repetirse utilizando los mismos archivos y parámetros.</a:t>
+              <a:t>El trabajo se desarrolló progresivamente en cuatro fases. En la Fase 1 realizamos la exploración inicial de los datos y definimos el problema. En la Fase 2 limpiamos, transformamos y validamos el conjunto de datos. En la Fase 3 reorganizamos la solución mediante programación orientada a objetos, comparamos distintos algoritmos para un mismo cálculo y optimizamos la lectura de los datos, midiendo la eficiencia de cada alternativa. Finalmente, en la Fase 4 construimos las visualizaciones utilizadas para comunicar los resultados. Todo el proceso quedó documentado para que pueda repetirse utilizando los mismos archivos y parámetros.</a:t>
             </a:r>
           </a:p>
         </p:txBody>
@@ -1510,7 +1510,7 @@
           </a:p>
           <a:p>
             <a:r>
-              <a:t>También evaluamos la eficiencia de la solución. La lectura selectiva de columnas redujo el tiempo aproximado del flujo completo desde 1.199 milisegundos hasta 506 milisegundos. La memoria ocupada por el conjunto de datos disminuyó desde aproximadamente 195,7 hasta 8,9 megabytes. Esto permite trabajar de una manera más rápida y con menos recursos. Para comprobar el funcionamiento se ejecutaron 29 pruebas asociadas al núcleo orientado a objetos y 10 pruebas relacionadas con las visualizaciones de la Fase 4.</a:t>
+              <a:t>También evaluamos la eficiencia de la solución. La lectura selectiva de columnas redujo el tiempo aproximado del flujo completo desde 1.199 milisegundos hasta 506 milisegundos. La memoria ocupada por el conjunto de datos disminuyó desde aproximadamente 196 hasta 9 megabytes. También comparamos tres formas de calcular las proporciones: iterativa, recursiva y agrupada. Las tres entregan el mismo resultado y la agrupada fue la más rápida. Para comprobar el funcionamiento se ejecutaron 39 pruebas: 14 de las clases, 8 de los algoritmos, 7 de la lectura y 10 de las visualizaciones.</a:t>
             </a:r>
           </a:p>
         </p:txBody>
@@ -1660,7 +1660,7 @@
           </a:p>
           <a:p>
             <a:r>
-              <a:t>En las licitaciones públicas superiores a 100 UTM observamos que el porcentaje de ofertas ganadoras disminuye a medida que aumenta la cuantía. La categoría LE alcanza un 62,3 %, LP un 56 % y LR un 51,5 %. Esto podría relacionarse con una competencia mayor o con requisitos más exigentes en los procesos de mayor monto. Las categorías privadas presentan muy pocos registros, por lo que sus porcentajes no deben interpretarse como una tendencia estable.</a:t>
+              <a:t>En las licitaciones públicas superiores a 100 UTM observamos que el porcentaje de ofertas ganadoras disminuye a medida que aumenta la cuantía. La categoría LE alcanza un 62,3 %, LP un 56 % y LR un 51,5 %. Es una asociación descriptiva: con estos datos no podemos afirmar a qué se debe. Las categorías privadas presentan muy pocos registros, por lo que sus porcentajes no deben interpretarse como una tendencia estable.</a:t>
             </a:r>
           </a:p>
         </p:txBody>
@@ -1735,7 +1735,7 @@
           </a:p>
           <a:p>
             <a:r>
-              <a:t>El tercer gráfico muestra que los plazos de cierre aumentan con la cuantía de la licitación. La mediana es de 7,2 días para L1, 11 días para LE, 20 días para LP y 32 días para LR. Este resultado es coherente con la mayor complejidad de los procedimientos de alto monto, ya que los proveedores necesitan más tiempo para preparar sus antecedentes y propuestas.</a:t>
+              <a:t>El tercer gráfico muestra que los plazos de cierre aumentan con la cuantía de la licitación. La mediana es de 7,2 días para L1, 11 días para LE, 20 días para LP y 32 días para LR. Calculamos el plazo por licitación y no por oferta, para que los procesos con más ofertas no pesen más. Es un resultado descriptivo: los procesos de mayor monto dan más tiempo para ofertar, pero los datos no explican la causa.</a:t>
             </a:r>
           </a:p>
         </p:txBody>
@@ -7259,7 +7259,7 @@
                 </a:solidFill>
                 <a:latin typeface="Calibri"/>
               </a:rPr>
-              <a:t>Limpieza, análisis descriptivo y primeras comparaciones.</a:t>
+              <a:t>Limpieza, transformación y validación del dataset.</a:t>
             </a:r>
           </a:p>
         </p:txBody>
@@ -7390,7 +7390,7 @@
                 </a:solidFill>
                 <a:latin typeface="Calibri"/>
               </a:rPr>
-              <a:t>Clases para lectura, limpieza, validación y ejecución del proceso.</a:t>
+              <a:t>Clases de lectura, limpieza y validación; algoritmos y lectura medidos.</a:t>
             </a:r>
           </a:p>
         </p:txBody>
@@ -7521,7 +7521,7 @@
                 </a:solidFill>
                 <a:latin typeface="Calibri"/>
               </a:rPr>
-              <a:t>Lectura optimizada, medición de eficiencia y visualizaciones.</a:t>
+              <a:t>Tres visualizaciones y comunicación de los resultados.</a:t>
             </a:r>
           </a:p>
         </p:txBody>
@@ -7607,16 +7607,7 @@
                 </a:solidFill>
                 <a:latin typeface="Calibri"/>
               </a:rPr>
-              <a:t>Reproducible: </a:t>
-            </a:r>
-            <a:r>
-              <a:rPr sz="1500" b="0" i="0">
-                <a:solidFill>
-                  <a:srgbClr val="1A2433"/>
-                </a:solidFill>
-                <a:latin typeface="Calibri"/>
-              </a:rPr>
-              <a:t>entorno virtual con Python 3.12 y requirements.txt, notebooks por fase, scripts de verificación y control de versiones con Git/GitHub y changelog.</a:t>
+              <a:t>Reproducible: entorno virtual con requirements.txt, notebooks por fase, scripts de verificación y control de versiones con Git/GitHub y changelog.</a:t>
             </a:r>
           </a:p>
         </p:txBody>
@@ -8838,16 +8829,7 @@
                 </a:solidFill>
                 <a:latin typeface="Calibri"/>
               </a:rPr>
-              <a:t>Corrección: </a:t>
-            </a:r>
-            <a:r>
-              <a:rPr sz="1400" b="0" i="0">
-                <a:solidFill>
-                  <a:srgbClr val="1A2433"/>
-                </a:solidFill>
-                <a:latin typeface="Calibri"/>
-              </a:rPr>
-              <a:t>con una lista vacía de reglas, el validador avisa que no hay reglas configuradas.</a:t>
+              <a:t>Caso de error cubierto: con una lista vacía de reglas, el validador avisa que no hay reglas configuradas.</a:t>
             </a:r>
           </a:p>
         </p:txBody>
@@ -9529,7 +9511,7 @@
         <p:spPr>
           <a:xfrm>
             <a:off x="548640" y="2057400"/>
-            <a:ext cx="3474720" cy="3108960"/>
+            <a:ext cx="3474720" cy="2697480"/>
           </a:xfrm>
           <a:prstGeom prst="roundRect">
             <a:avLst>
@@ -9693,7 +9675,7 @@
         <p:spPr>
           <a:xfrm>
             <a:off x="4297679" y="2057400"/>
-            <a:ext cx="3474720" cy="3108960"/>
+            <a:ext cx="3474720" cy="2697480"/>
           </a:xfrm>
           <a:prstGeom prst="roundRect">
             <a:avLst>
@@ -9843,7 +9825,7 @@
                 </a:solidFill>
                 <a:latin typeface="Calibri"/>
               </a:rPr>
-              <a:t>195,7 MB  →  8,9 MB</a:t>
+              <a:t>195,7 MiB  →  8,9 MiB</a:t>
             </a:r>
           </a:p>
         </p:txBody>
@@ -9857,7 +9839,7 @@
         <p:spPr>
           <a:xfrm>
             <a:off x="8046719" y="2057400"/>
-            <a:ext cx="3474720" cy="3108960"/>
+            <a:ext cx="3474720" cy="2697480"/>
           </a:xfrm>
           <a:prstGeom prst="roundRect">
             <a:avLst>
@@ -10007,7 +9989,7 @@
                 </a:solidFill>
                 <a:latin typeface="Calibri"/>
               </a:rPr>
-              <a:t>29 del núcleo POO + 10 de visualizaciones</a:t>
+              <a:t>14 de POO, 8 de algoritmos, 7 de lectura y 10 de visualizaciones</a:t>
             </a:r>
           </a:p>
         </p:txBody>
@@ -10020,8 +10002,8 @@
         </p:nvSpPr>
         <p:spPr>
           <a:xfrm>
-            <a:off x="548640" y="5486400"/>
-            <a:ext cx="11064240" cy="640080"/>
+            <a:off x="548640" y="5806440"/>
+            <a:ext cx="11064240" cy="457200"/>
           </a:xfrm>
           <a:prstGeom prst="rect">
             <a:avLst/>
@@ -10046,7 +10028,74 @@
                 </a:solidFill>
                 <a:latin typeface="Calibri"/>
               </a:rPr>
-              <a:t>Resultado: el mismo análisis se ejecuta en menos de la mitad del tiempo y con una fracción de la memoria.</a:t>
+              <a:t>Mismo análisis en menos de la mitad del tiempo. Entre los algoritmos iterativo, recursivo y agrupado, el agrupado fue el más rápido.</a:t>
+            </a:r>
+          </a:p>
+        </p:txBody>
+      </p:sp>
+      <p:sp>
+        <p:nvSpPr>
+          <p:cNvPr id="20" name="Evidencia de ejecución"/>
+          <p:cNvSpPr/>
+          <p:nvPr/>
+        </p:nvSpPr>
+        <p:spPr>
+          <a:xfrm>
+            <a:off x="548640" y="4937760"/>
+            <a:ext cx="10972800" cy="777240"/>
+          </a:xfrm>
+          <a:prstGeom prst="roundRect">
+            <a:avLst>
+              <a:gd name="adj" fmla="val 12000"/>
+            </a:avLst>
+          </a:prstGeom>
+          <a:solidFill>
+            <a:srgbClr val="1F2933"/>
+          </a:solidFill>
+          <a:ln>
+            <a:noFill/>
+          </a:ln>
+          <a:effectLst/>
+        </p:spPr>
+        <p:style>
+          <a:lnRef idx="1">
+            <a:schemeClr val="accent1"/>
+          </a:lnRef>
+          <a:fillRef idx="3">
+            <a:schemeClr val="accent1"/>
+          </a:fillRef>
+          <a:effectRef idx="2">
+            <a:schemeClr val="accent1"/>
+          </a:effectRef>
+          <a:fontRef idx="minor">
+            <a:schemeClr val="lt1"/>
+          </a:fontRef>
+        </p:style>
+        <p:txBody>
+          <a:bodyPr rtlCol="0" anchor="ctr" lIns="228600"/>
+          <a:lstStyle/>
+          <a:p>
+            <a:pPr algn="l"/>
+            <a:r>
+              <a:rPr sz="1200">
+                <a:solidFill>
+                  <a:srgbClr val="E6EDF3"/>
+                </a:solidFill>
+                <a:latin typeface="Consolas"/>
+              </a:rPr>
+              <a:t>&gt; python -m unittest F3.test_algoritmos F3.test_nucleo_poo F3.test_lectura F4.test_visualizacion   →   Ran 39 tests · OK</a:t>
+            </a:r>
+          </a:p>
+          <a:p>
+            <a:pPr algn="l"/>
+            <a:r>
+              <a:rPr sz="1200">
+                <a:solidFill>
+                  <a:srgbClr val="E6EDF3"/>
+                </a:solidFill>
+                <a:latin typeface="Consolas"/>
+              </a:rPr>
+              <a:t>&gt; python F4\verificar_f4.py   →   10 celdas ejecutadas · 0 errores</a:t>
             </a:r>
           </a:p>
         </p:txBody>
@@ -10203,102 +10252,6 @@
       </p:sp>
       <p:sp>
         <p:nvSpPr>
-          <p:cNvPr id="6" name="TextBox 5"/>
-          <p:cNvSpPr txBox="1"/>
-          <p:nvPr/>
-        </p:nvSpPr>
-        <p:spPr>
-          <a:xfrm>
-            <a:off x="548640" y="1325880"/>
-            <a:ext cx="6949440" cy="365760"/>
-          </a:xfrm>
-          <a:prstGeom prst="rect">
-            <a:avLst/>
-          </a:prstGeom>
-          <a:noFill/>
-        </p:spPr>
-        <p:txBody>
-          <a:bodyPr wrap="square" lIns="0" tIns="0" rIns="0" bIns="0" anchor="t">
-            <a:spAutoFit/>
-          </a:bodyPr>
-          <a:lstStyle/>
-          <a:p>
-            <a:pPr algn="l">
-              <a:spcAft>
-                <a:spcPts val="0"/>
-              </a:spcAft>
-            </a:pPr>
-            <a:r>
-              <a:rPr sz="1400" b="0" i="0">
-                <a:solidFill>
-                  <a:srgbClr val="5B677A"/>
-                </a:solidFill>
-                <a:latin typeface="Calibri"/>
-              </a:rPr>
-              <a:t>Ofertas ganadoras según tamaño del proveedor (% de ofertas con resultado válido)</a:t>
-            </a:r>
-          </a:p>
-        </p:txBody>
-      </p:sp>
-      <p:graphicFrame>
-        <p:nvGraphicFramePr>
-          <p:cNvPr id="7" name="Chart 6"/>
-          <p:cNvGraphicFramePr>
-            <a:graphicFrameLocks noGrp="1"/>
-          </p:cNvGraphicFramePr>
-          <p:nvPr/>
-        </p:nvGraphicFramePr>
-        <p:xfrm>
-          <a:off x="365760" y="1691640"/>
-          <a:ext cx="7223760" cy="4206240"/>
-        </p:xfrm>
-        <a:graphic>
-          <a:graphicData uri="http://schemas.openxmlformats.org/drawingml/2006/chart">
-            <c:chart xmlns:c="http://schemas.openxmlformats.org/drawingml/2006/chart" xmlns:r="http://schemas.openxmlformats.org/officeDocument/2006/relationships" r:id="rId3"/>
-          </a:graphicData>
-        </a:graphic>
-      </p:graphicFrame>
-      <p:sp>
-        <p:nvSpPr>
-          <p:cNvPr id="8" name="TextBox 7"/>
-          <p:cNvSpPr txBox="1"/>
-          <p:nvPr/>
-        </p:nvSpPr>
-        <p:spPr>
-          <a:xfrm>
-            <a:off x="548640" y="5989320"/>
-            <a:ext cx="7315200" cy="274320"/>
-          </a:xfrm>
-          <a:prstGeom prst="rect">
-            <a:avLst/>
-          </a:prstGeom>
-          <a:noFill/>
-        </p:spPr>
-        <p:txBody>
-          <a:bodyPr wrap="square" lIns="0" tIns="0" rIns="0" bIns="0" anchor="t">
-            <a:spAutoFit/>
-          </a:bodyPr>
-          <a:lstStyle/>
-          <a:p>
-            <a:pPr algn="l">
-              <a:spcAft>
-                <a:spcPts val="0"/>
-              </a:spcAft>
-            </a:pPr>
-            <a:r>
-              <a:rPr sz="1000" b="0" i="1">
-                <a:solidFill>
-                  <a:srgbClr val="5B677A"/>
-                </a:solidFill>
-                <a:latin typeface="Calibri"/>
-              </a:rPr>
-              <a:t>Procesos adjudicados. Promedio general: 59,2 %. Fuente: elaboración propia con datos abiertos de ChileCompra.</a:t>
-            </a:r>
-          </a:p>
-        </p:txBody>
-      </p:sp>
-      <p:sp>
-        <p:nvSpPr>
           <p:cNvPr id="9" name="Rounded Rectangle 8"/>
           <p:cNvSpPr/>
           <p:nvPr/>
@@ -10548,6 +10501,30 @@
           </a:p>
         </p:txBody>
       </p:sp>
+      <p:pic>
+        <p:nvPicPr>
+          <p:cNvPr id="15" name="Figura notebook F4" descr="grafico1_tamano_proveedor.png"/>
+          <p:cNvPicPr>
+            <a:picLocks noChangeAspect="1"/>
+          </p:cNvPicPr>
+          <p:nvPr/>
+        </p:nvPicPr>
+        <p:blipFill>
+          <a:blip r:embed="rId4"/>
+          <a:stretch>
+            <a:fillRect/>
+          </a:stretch>
+        </p:blipFill>
+        <p:spPr>
+          <a:xfrm>
+            <a:off x="457200" y="1796314"/>
+            <a:ext cx="7315200" cy="4042610"/>
+          </a:xfrm>
+          <a:prstGeom prst="rect">
+            <a:avLst/>
+          </a:prstGeom>
+        </p:spPr>
+      </p:pic>
     </p:spTree>
   </p:cSld>
   <p:clrMapOvr>
@@ -10700,102 +10677,6 @@
       </p:sp>
       <p:sp>
         <p:nvSpPr>
-          <p:cNvPr id="6" name="TextBox 5"/>
-          <p:cNvSpPr txBox="1"/>
-          <p:nvPr/>
-        </p:nvSpPr>
-        <p:spPr>
-          <a:xfrm>
-            <a:off x="548640" y="1325880"/>
-            <a:ext cx="6949440" cy="365760"/>
-          </a:xfrm>
-          <a:prstGeom prst="rect">
-            <a:avLst/>
-          </a:prstGeom>
-          <a:noFill/>
-        </p:spPr>
-        <p:txBody>
-          <a:bodyPr wrap="square" lIns="0" tIns="0" rIns="0" bIns="0" anchor="t">
-            <a:spAutoFit/>
-          </a:bodyPr>
-          <a:lstStyle/>
-          <a:p>
-            <a:pPr algn="l">
-              <a:spcAft>
-                <a:spcPts val="0"/>
-              </a:spcAft>
-            </a:pPr>
-            <a:r>
-              <a:rPr sz="1400" b="0" i="0">
-                <a:solidFill>
-                  <a:srgbClr val="5B677A"/>
-                </a:solidFill>
-                <a:latin typeface="Calibri"/>
-              </a:rPr>
-              <a:t>Ofertas ganadoras en licitaciones públicas, ordenadas por cuantía (%)</a:t>
-            </a:r>
-          </a:p>
-        </p:txBody>
-      </p:sp>
-      <p:graphicFrame>
-        <p:nvGraphicFramePr>
-          <p:cNvPr id="7" name="Chart 6"/>
-          <p:cNvGraphicFramePr>
-            <a:graphicFrameLocks noGrp="1"/>
-          </p:cNvGraphicFramePr>
-          <p:nvPr/>
-        </p:nvGraphicFramePr>
-        <p:xfrm>
-          <a:off x="365760" y="1691640"/>
-          <a:ext cx="7223760" cy="4206240"/>
-        </p:xfrm>
-        <a:graphic>
-          <a:graphicData uri="http://schemas.openxmlformats.org/drawingml/2006/chart">
-            <c:chart xmlns:c="http://schemas.openxmlformats.org/drawingml/2006/chart" xmlns:r="http://schemas.openxmlformats.org/officeDocument/2006/relationships" r:id="rId3"/>
-          </a:graphicData>
-        </a:graphic>
-      </p:graphicFrame>
-      <p:sp>
-        <p:nvSpPr>
-          <p:cNvPr id="8" name="TextBox 7"/>
-          <p:cNvSpPr txBox="1"/>
-          <p:nvPr/>
-        </p:nvSpPr>
-        <p:spPr>
-          <a:xfrm>
-            <a:off x="548640" y="5989320"/>
-            <a:ext cx="7315200" cy="274320"/>
-          </a:xfrm>
-          <a:prstGeom prst="rect">
-            <a:avLst/>
-          </a:prstGeom>
-          <a:noFill/>
-        </p:spPr>
-        <p:txBody>
-          <a:bodyPr wrap="square" lIns="0" tIns="0" rIns="0" bIns="0" anchor="t">
-            <a:spAutoFit/>
-          </a:bodyPr>
-          <a:lstStyle/>
-          <a:p>
-            <a:pPr algn="l">
-              <a:spcAft>
-                <a:spcPts val="0"/>
-              </a:spcAft>
-            </a:pPr>
-            <a:r>
-              <a:rPr sz="1000" b="0" i="1">
-                <a:solidFill>
-                  <a:srgbClr val="5B677A"/>
-                </a:solidFill>
-                <a:latin typeface="Calibri"/>
-              </a:rPr>
-              <a:t>Procesos adjudicados. Fuente: elaboración propia con datos abiertos de ChileCompra.</a:t>
-            </a:r>
-          </a:p>
-        </p:txBody>
-      </p:sp>
-      <p:sp>
-        <p:nvSpPr>
           <p:cNvPr id="9" name="Rounded Rectangle 8"/>
           <p:cNvSpPr/>
           <p:nvPr/>
@@ -11307,20 +11188,35 @@
                 </a:solidFill>
                 <a:latin typeface="Calibri"/>
               </a:rPr>
-              <a:t>Posibles causas: </a:t>
-            </a:r>
-            <a:r>
-              <a:rPr sz="1400" b="0" i="0">
-                <a:solidFill>
-                  <a:srgbClr val="1A2433"/>
-                </a:solidFill>
-                <a:latin typeface="Calibri"/>
-              </a:rPr>
-              <a:t>más competencia o requisitos más exigentes. Las privadas tienen muy pocos registros y no se interpretan como tendencia.</a:t>
-            </a:r>
-          </a:p>
-        </p:txBody>
-      </p:sp>
+              <a:t>Es una asociación descriptiva: los datos no permiten atribuirla a una causa. Las privadas tienen muy pocos registros y no se interpretan como tendencia.</a:t>
+            </a:r>
+          </a:p>
+        </p:txBody>
+      </p:sp>
+      <p:pic>
+        <p:nvPicPr>
+          <p:cNvPr id="21" name="Figura notebook F4" descr="grafico2_tipo_licitacion.png"/>
+          <p:cNvPicPr>
+            <a:picLocks noChangeAspect="1"/>
+          </p:cNvPicPr>
+          <p:nvPr/>
+        </p:nvPicPr>
+        <p:blipFill>
+          <a:blip r:embed="rId4"/>
+          <a:stretch>
+            <a:fillRect/>
+          </a:stretch>
+        </p:blipFill>
+        <p:spPr>
+          <a:xfrm>
+            <a:off x="573258" y="1394460"/>
+            <a:ext cx="7083083" cy="4846320"/>
+          </a:xfrm>
+          <a:prstGeom prst="rect">
+            <a:avLst/>
+          </a:prstGeom>
+        </p:spPr>
+      </p:pic>
     </p:spTree>
   </p:cSld>
   <p:clrMapOvr>
@@ -11473,102 +11369,6 @@
       </p:sp>
       <p:sp>
         <p:nvSpPr>
-          <p:cNvPr id="6" name="TextBox 5"/>
-          <p:cNvSpPr txBox="1"/>
-          <p:nvPr/>
-        </p:nvSpPr>
-        <p:spPr>
-          <a:xfrm>
-            <a:off x="548640" y="1325880"/>
-            <a:ext cx="6949440" cy="365760"/>
-          </a:xfrm>
-          <a:prstGeom prst="rect">
-            <a:avLst/>
-          </a:prstGeom>
-          <a:noFill/>
-        </p:spPr>
-        <p:txBody>
-          <a:bodyPr wrap="square" lIns="0" tIns="0" rIns="0" bIns="0" anchor="t">
-            <a:spAutoFit/>
-          </a:bodyPr>
-          <a:lstStyle/>
-          <a:p>
-            <a:pPr algn="l">
-              <a:spcAft>
-                <a:spcPts val="0"/>
-              </a:spcAft>
-            </a:pPr>
-            <a:r>
-              <a:rPr sz="1400" b="0" i="0">
-                <a:solidFill>
-                  <a:srgbClr val="5B677A"/>
-                </a:solidFill>
-                <a:latin typeface="Calibri"/>
-              </a:rPr>
-              <a:t>Mediana de días entre publicación y cierre, por tipo de licitación pública</a:t>
-            </a:r>
-          </a:p>
-        </p:txBody>
-      </p:sp>
-      <p:graphicFrame>
-        <p:nvGraphicFramePr>
-          <p:cNvPr id="7" name="Chart 6"/>
-          <p:cNvGraphicFramePr>
-            <a:graphicFrameLocks noGrp="1"/>
-          </p:cNvGraphicFramePr>
-          <p:nvPr/>
-        </p:nvGraphicFramePr>
-        <p:xfrm>
-          <a:off x="365760" y="1691640"/>
-          <a:ext cx="7223760" cy="4206240"/>
-        </p:xfrm>
-        <a:graphic>
-          <a:graphicData uri="http://schemas.openxmlformats.org/drawingml/2006/chart">
-            <c:chart xmlns:c="http://schemas.openxmlformats.org/drawingml/2006/chart" xmlns:r="http://schemas.openxmlformats.org/officeDocument/2006/relationships" r:id="rId3"/>
-          </a:graphicData>
-        </a:graphic>
-      </p:graphicFrame>
-      <p:sp>
-        <p:nvSpPr>
-          <p:cNvPr id="8" name="TextBox 7"/>
-          <p:cNvSpPr txBox="1"/>
-          <p:nvPr/>
-        </p:nvSpPr>
-        <p:spPr>
-          <a:xfrm>
-            <a:off x="548640" y="5989320"/>
-            <a:ext cx="7315200" cy="274320"/>
-          </a:xfrm>
-          <a:prstGeom prst="rect">
-            <a:avLst/>
-          </a:prstGeom>
-          <a:noFill/>
-        </p:spPr>
-        <p:txBody>
-          <a:bodyPr wrap="square" lIns="0" tIns="0" rIns="0" bIns="0" anchor="t">
-            <a:spAutoFit/>
-          </a:bodyPr>
-          <a:lstStyle/>
-          <a:p>
-            <a:pPr algn="l">
-              <a:spcAft>
-                <a:spcPts val="0"/>
-              </a:spcAft>
-            </a:pPr>
-            <a:r>
-              <a:rPr sz="1000" b="0" i="1">
-                <a:solidFill>
-                  <a:srgbClr val="5B677A"/>
-                </a:solidFill>
-                <a:latin typeface="Calibri"/>
-              </a:rPr>
-              <a:t>Una observación por licitación. Fuente: elaboración propia con datos abiertos de ChileCompra.</a:t>
-            </a:r>
-          </a:p>
-        </p:txBody>
-      </p:sp>
-      <p:sp>
-        <p:nvSpPr>
           <p:cNvPr id="9" name="Rounded Rectangle 8"/>
           <p:cNvSpPr/>
           <p:nvPr/>
@@ -11726,11 +11526,35 @@
                 </a:solidFill>
                 <a:latin typeface="Calibri"/>
               </a:rPr>
-              <a:t>Coherente con procesos más complejos: los proveedores necesitan más tiempo para preparar antecedentes y propuestas.</a:t>
-            </a:r>
-          </a:p>
-        </p:txBody>
-      </p:sp>
+              <a:t>Se calcula con una observación por licitación (1.864 procesos), para que los procesos con más ofertas no pesen más.</a:t>
+            </a:r>
+          </a:p>
+        </p:txBody>
+      </p:sp>
+      <p:pic>
+        <p:nvPicPr>
+          <p:cNvPr id="13" name="Figura notebook F4" descr="grafico3_plazo_cierre.png"/>
+          <p:cNvPicPr>
+            <a:picLocks noChangeAspect="1"/>
+          </p:cNvPicPr>
+          <p:nvPr/>
+        </p:nvPicPr>
+        <p:blipFill>
+          <a:blip r:embed="rId4"/>
+          <a:stretch>
+            <a:fillRect/>
+          </a:stretch>
+        </p:blipFill>
+        <p:spPr>
+          <a:xfrm>
+            <a:off x="666107" y="1394460"/>
+            <a:ext cx="6897384" cy="4846320"/>
+          </a:xfrm>
+          <a:prstGeom prst="rect">
+            <a:avLst/>
+          </a:prstGeom>
+        </p:spPr>
+      </p:pic>
     </p:spTree>
   </p:cSld>
   <p:clrMapOvr>

</xml_diff>